<commit_message>
add streamlines to header slide
</commit_message>
<xml_diff>
--- a/pitch/oma-pitch-template.pptx
+++ b/pitch/oma-pitch-template.pptx
@@ -3114,12 +3114,20 @@
         <p:nvPr/>
       </p:nvGrpSpPr>
       <p:grpSpPr/>
-      <p:sp>
-        <p:nvSpPr>
-          <p:cNvPr id="2" name="Rectangle 1"/>
-          <p:cNvSpPr/>
+      <p:pic>
+        <p:nvPicPr>
+          <p:cNvPr id="2" name="Picture 1" descr="hero-streamlines.png"/>
+          <p:cNvPicPr>
+            <a:picLocks noChangeAspect="1"/>
+          </p:cNvPicPr>
           <p:nvPr/>
-        </p:nvSpPr>
+        </p:nvPicPr>
+        <p:blipFill>
+          <a:blip r:embed="rId2"/>
+          <a:stretch>
+            <a:fillRect/>
+          </a:stretch>
+        </p:blipFill>
         <p:spPr>
           <a:xfrm>
             <a:off x="0" y="0"/>
@@ -3128,22 +3136,8 @@
           <a:prstGeom prst="rect">
             <a:avLst/>
           </a:prstGeom>
-          <a:solidFill>
-            <a:srgbClr val="050F1C"/>
-          </a:solidFill>
-          <a:ln>
-            <a:noFill/>
-          </a:ln>
-          <a:effectLst/>
-        </p:spPr>
-        <p:txBody>
-          <a:bodyPr rtlCol="0" anchor="ctr"/>
-          <a:lstStyle/>
-          <a:p>
-            <a:pPr algn="ctr"/>
-          </a:p>
-        </p:txBody>
-      </p:sp>
+        </p:spPr>
+      </p:pic>
       <p:sp>
         <p:nvSpPr>
           <p:cNvPr id="3" name="Rectangle 2"/>
@@ -3183,7 +3177,7 @@
           <p:nvPr/>
         </p:nvPicPr>
         <p:blipFill>
-          <a:blip r:embed="rId2"/>
+          <a:blip r:embed="rId3"/>
           <a:stretch>
             <a:fillRect/>
           </a:stretch>

</xml_diff>